<commit_message>
update pptx version of the tempalte
</commit_message>
<xml_diff>
--- a/pptx/crns_template.pptx
+++ b/pptx/crns_template.pptx
@@ -123,26 +123,26 @@
   <p:extLst>
     <p:ext uri="{521415D9-36F7-43E2-AB2F-B90AF26B5E84}">
       <p14:sectionLst xmlns:p14="http://schemas.microsoft.com/office/powerpoint/2010/main">
-        <p14:section name="Introduction" id="{2f68c573-2e9f-f6fd-fc2c-176a6aae4232}">
+        <p14:section name="Introduction" id="{caeaa9e0-f1a8-6d63-dff1-9cbe25b93b0d}">
           <p14:sldIdLst>
             <p14:sldId id="256"/>
             <p14:sldId id="257"/>
           </p14:sldIdLst>
         </p14:section>
-        <p14:section name="Section 1" id="{3c0f7cc4-9019-e080-a895-c5d881ec3415}">
+        <p14:section name="Section 1" id="{b381434a-9a6d-7e7d-4c88-04807f0c7322}">
           <p14:sldIdLst>
             <p14:sldId id="258"/>
             <p14:sldId id="259"/>
             <p14:sldId id="260"/>
           </p14:sldIdLst>
         </p14:section>
-        <p14:section name="Section 2" id="{05ff2b74-c7dd-470c-66c3-8991c24bfcde}">
+        <p14:section name="Section 2" id="{e7d12e26-6ff4-5905-b197-9e2c67d3b37f}">
           <p14:sldIdLst>
             <p14:sldId id="261"/>
             <p14:sldId id="262"/>
           </p14:sldIdLst>
         </p14:section>
-        <p14:section name="Elements" id="{0df0cb1c-209f-1994-8756-fda6dad74810}">
+        <p14:section name="Elements" id="{3f76713a-2ba5-d7e0-c41c-de6a523ab571}">
           <p14:sldIdLst>
             <p14:sldId id="263"/>
             <p14:sldId id="264"/>
@@ -155,7 +155,7 @@
             <p14:sldId id="271"/>
           </p14:sldIdLst>
         </p14:section>
-        <p14:section name="Closing" id="{3dacf71f-fb50-6a31-360d-72ddbb3e18cd}">
+        <p14:section name="Closing" id="{6c9262b7-bc5f-4279-2063-68e89bc813db}">
           <p14:sldIdLst>
             <p14:sldId id="272"/>
           </p14:sldIdLst>

</xml_diff>